<commit_message>
Rebuild churn model with leak-free evaluation, SHAP, ROI and SQL layer
- Replace original notebook with Telecom_HVC_Churn_Model.ipynb:
  60/20/20 train/validation/test split, scikit-learn pipelines
  (capping, scaling, PCA fitted on train only), threshold chosen on
  validation for F2, results reported once on the hold-out test set
- Add SHAP explainability, cost-benefit analysis with sensitivity table
- Export anonymised risk scores and add DuckDB SQL queries
  (revenue at risk by tier, decile lift, priority call list)
- Rewrite README to match the code exactly; add requirements.txt
- Update strategy deck with hold-out results
- Add author credit to README, notebook and deck
</commit_message>
<xml_diff>
--- a/churn_analysis.pptx
+++ b/churn_analysis.pptx
@@ -236,10 +236,10 @@
                   <c:v>Recall</c:v>
                 </c:pt>
                 <c:pt idx="1">
-                  <c:v>Accuracy</c:v>
+                  <c:v>Precision</c:v>
                 </c:pt>
                 <c:pt idx="2">
-                  <c:v>Precision</c:v>
+                  <c:v>Random targeting</c:v>
                 </c:pt>
               </c:strCache>
             </c:strRef>
@@ -251,13 +251,13 @@
                 <c:formatCode>General</c:formatCode>
                 <c:ptCount val="3"/>
                 <c:pt idx="0">
-                  <c:v>82</c:v>
+                  <c:v>83</c:v>
                 </c:pt>
                 <c:pt idx="1">
-                  <c:v>90</c:v>
+                  <c:v>45.5</c:v>
                 </c:pt>
                 <c:pt idx="2">
-                  <c:v>45</c:v>
+                  <c:v>8.6</c:v>
                 </c:pt>
               </c:numCache>
             </c:numRef>
@@ -1338,7 +1338,7 @@
                 <a:ea typeface="Calibri" pitchFamily="34" charset="-122"/>
                 <a:cs typeface="Calibri" pitchFamily="34" charset="-120"/>
               </a:rPr>
-              <a:t>80%</a:t>
+              <a:t>63%</a:t>
             </a:r>
             <a:endParaRPr lang="en-US" sz="3800" dirty="0"/>
           </a:p>
@@ -1380,7 +1380,7 @@
                 <a:ea typeface="Calibri" pitchFamily="34" charset="-122"/>
                 <a:cs typeface="Calibri" pitchFamily="34" charset="-120"/>
               </a:rPr>
-              <a:t>of total revenue driven by</a:t>
+              <a:t>of total ARPU driven by</a:t>
             </a:r>
             <a:endParaRPr lang="en-US" sz="950" dirty="0"/>
           </a:p>
@@ -1400,7 +1400,7 @@
                 <a:ea typeface="Calibri" pitchFamily="34" charset="-122"/>
                 <a:cs typeface="Calibri" pitchFamily="34" charset="-120"/>
               </a:rPr>
-              <a:t>the top 20% of subscribers</a:t>
+              <a:t>the top 30% of subscribers</a:t>
             </a:r>
             <a:endParaRPr lang="en-US" sz="950" dirty="0"/>
           </a:p>
@@ -1725,7 +1725,7 @@
                   <a:srgbClr val="A8C4E0"/>
                 </a:solidFill>
               </a:rPr>
-              <a:t>Exclusive focus on High-Value Customers — the top 20% of revenue generators.</a:t>
+              <a:t>Exclusive focus on High-Value Customers — the top 30% by good-phase recharge (70th percentile).</a:t>
             </a:r>
             <a:endParaRPr lang="en-US" sz="1000" dirty="0"/>
           </a:p>
@@ -1743,7 +1743,7 @@
                   <a:srgbClr val="A8C4E0"/>
                 </a:solidFill>
               </a:rPr>
-              <a:t>This segment collectively accounts for 80% of total revenue.</a:t>
+              <a:t>This segment of 30,011 subscribers accounts for ~63% of total ARPU.</a:t>
             </a:r>
             <a:endParaRPr lang="en-US" sz="1000" dirty="0"/>
           </a:p>
@@ -2708,7 +2708,7 @@
                 <a:ea typeface="Calibri" pitchFamily="34" charset="-122"/>
                 <a:cs typeface="Calibri" pitchFamily="34" charset="-120"/>
               </a:rPr>
-              <a:t>Dual-Engine Architecture</a:t>
+              <a:t>Model &amp; Explainability</a:t>
             </a:r>
             <a:endParaRPr lang="en-US" sz="1200" dirty="0"/>
           </a:p>
@@ -2818,7 +2818,7 @@
                   <a:srgbClr val="FFFFFF"/>
                 </a:solidFill>
               </a:rPr>
-              <a:t>Tactical Engine — </a:t>
+              <a:t>Tactical Engine — Random Forest Classifier — selected on validation PR-AUC, threshold tuned for F2</a:t>
             </a:r>
             <a:r>
               <a:rPr lang="en-US" sz="900" dirty="0">
@@ -2826,7 +2826,7 @@
                   <a:srgbClr val="A8C4E0"/>
                 </a:solidFill>
               </a:rPr>
-              <a:t>Gradient Boosting Classifier — optimised for high-recall churn prediction</a:t>
+              <a:t/>
             </a:r>
             <a:endParaRPr lang="en-US" sz="900" dirty="0"/>
           </a:p>
@@ -2936,7 +2936,7 @@
                   <a:srgbClr val="FFFFFF"/>
                 </a:solidFill>
               </a:rPr>
-              <a:t>Strategic Model — </a:t>
+              <a:t>Explainability Layer — SHAP values — customer-level churn drivers</a:t>
             </a:r>
             <a:r>
               <a:rPr lang="en-US" sz="900" dirty="0">
@@ -2944,7 +2944,7 @@
                   <a:srgbClr val="A8C4E0"/>
                 </a:solidFill>
               </a:rPr>
-              <a:t>Lasso-regularised Logistic Regression — behavioural feature interpretability</a:t>
+              <a:t/>
             </a:r>
             <a:endParaRPr lang="en-US" sz="900" dirty="0"/>
           </a:p>
@@ -3211,7 +3211,7 @@
                   <a:srgbClr val="FFFFFF"/>
                 </a:solidFill>
               </a:rPr>
-              <a:t>Social Connectivity — </a:t>
+              <a:t>Social Connectivity — Collapse of incoming minutes, including from other networks</a:t>
             </a:r>
             <a:r>
               <a:rPr lang="en-US" sz="900" dirty="0">
@@ -3219,7 +3219,7 @@
                   <a:srgbClr val="A8C4E0"/>
                 </a:solidFill>
               </a:rPr>
-              <a:t>Collapse of incoming local minutes from other networks</a:t>
+              <a:t/>
             </a:r>
             <a:endParaRPr lang="en-US" sz="900" dirty="0"/>
           </a:p>
@@ -3297,7 +3297,7 @@
                   <a:srgbClr val="FFFFFF"/>
                 </a:solidFill>
               </a:rPr>
-              <a:t>Data Dependency — </a:t>
+              <a:t>Mobility Shift — Rising roaming usage in Month 8</a:t>
             </a:r>
             <a:r>
               <a:rPr lang="en-US" sz="900" dirty="0">
@@ -3305,7 +3305,7 @@
                   <a:srgbClr val="A8C4E0"/>
                 </a:solidFill>
               </a:rPr>
-              <a:t>Absence of active 3G / 4G monthly data packs</a:t>
+              <a:t/>
             </a:r>
             <a:endParaRPr lang="en-US" sz="900" dirty="0"/>
           </a:p>
@@ -3447,7 +3447,7 @@
                 <a:ea typeface="Calibri" pitchFamily="34" charset="-122"/>
                 <a:cs typeface="Calibri" pitchFamily="34" charset="-120"/>
               </a:rPr>
-              <a:t>82%</a:t>
+              <a:t>83%</a:t>
             </a:r>
             <a:endParaRPr lang="en-US" sz="4600" dirty="0"/>
           </a:p>
@@ -3489,7 +3489,7 @@
                 <a:ea typeface="Calibri" pitchFamily="34" charset="-122"/>
                 <a:cs typeface="Calibri" pitchFamily="34" charset="-120"/>
               </a:rPr>
-              <a:t>82 of 100 churners captured</a:t>
+              <a:t>83 of 100 churners captured (hold-out test)</a:t>
             </a:r>
             <a:endParaRPr lang="en-US" sz="750" dirty="0"/>
           </a:p>
@@ -3663,7 +3663,7 @@
                 <a:ea typeface="Calibri" pitchFamily="34" charset="-122"/>
                 <a:cs typeface="Calibri" pitchFamily="34" charset="-120"/>
               </a:rPr>
-              <a:t>ACCURACY</a:t>
+              <a:t>LIFT</a:t>
             </a:r>
             <a:endParaRPr lang="en-US" sz="700" dirty="0"/>
           </a:p>
@@ -3702,7 +3702,7 @@
                 <a:ea typeface="Calibri" pitchFamily="34" charset="-122"/>
                 <a:cs typeface="Calibri" pitchFamily="34" charset="-120"/>
               </a:rPr>
-              <a:t>90%</a:t>
+              <a:t>5.3x</a:t>
             </a:r>
             <a:endParaRPr lang="en-US" sz="4000" dirty="0"/>
           </a:p>
@@ -3744,7 +3744,7 @@
                 <a:ea typeface="Calibri" pitchFamily="34" charset="-122"/>
                 <a:cs typeface="Calibri" pitchFamily="34" charset="-120"/>
               </a:rPr>
-              <a:t>Overall model accuracy</a:t>
+              <a:t>Precision vs random targeting</a:t>
             </a:r>
             <a:endParaRPr lang="en-US" sz="750" dirty="0"/>
           </a:p>
@@ -3886,7 +3886,7 @@
                 <a:ea typeface="Calibri" pitchFamily="34" charset="-122"/>
                 <a:cs typeface="Calibri" pitchFamily="34" charset="-120"/>
               </a:rPr>
-              <a:t>45%</a:t>
+              <a:t>46%</a:t>
             </a:r>
             <a:endParaRPr lang="en-US" sz="4000" dirty="0"/>
           </a:p>
@@ -3999,7 +3999,7 @@
                   <a:srgbClr val="E8A020"/>
                 </a:solidFill>
               </a:rPr>
-              <a:t>Recall (82%)</a:t>
+              <a:t>Recall (83%, untouched hold-out set) is the primary success metric — every churner the model misses represents an unrecoverable revenue loss from the highest-value customer segment.</a:t>
             </a:r>
             <a:r>
               <a:rPr lang="en-US" sz="950" dirty="0">
@@ -4007,7 +4007,7 @@
                   <a:srgbClr val="A8C4E0"/>
                 </a:solidFill>
               </a:rPr>
-              <a:t> is the primary success metric — every churner the model misses represents an unrecoverable revenue loss from the highest-value customer segment.</a:t>
+              <a:t/>
             </a:r>
             <a:endParaRPr lang="en-US" sz="1000" dirty="0"/>
           </a:p>

</xml_diff>